<commit_message>
Avances finales en construcción de modelo estrella, finalización de creación de facto y dimensiones
</commit_message>
<xml_diff>
--- a/Documentos/Presentación.pptx
+++ b/Documentos/Presentación.pptx
@@ -112,12 +112,12 @@
   <pc:docChgLst>
     <pc:chgData name="Diego Hernando Miranda Jimenez" userId="4eb28599-f441-4de0-a58d-80b2e80d624c" providerId="ADAL" clId="{4DB6BEFE-0A31-43AF-A2A0-D92ECB6A0142}"/>
     <pc:docChg chg="custSel addSld modSld">
-      <pc:chgData name="Diego Hernando Miranda Jimenez" userId="4eb28599-f441-4de0-a58d-80b2e80d624c" providerId="ADAL" clId="{4DB6BEFE-0A31-43AF-A2A0-D92ECB6A0142}" dt="2026-04-01T16:18:35.059" v="4" actId="1076"/>
+      <pc:chgData name="Diego Hernando Miranda Jimenez" userId="4eb28599-f441-4de0-a58d-80b2e80d624c" providerId="ADAL" clId="{4DB6BEFE-0A31-43AF-A2A0-D92ECB6A0142}" dt="2026-04-02T00:01:28.390" v="5" actId="1076"/>
       <pc:docMkLst>
         <pc:docMk/>
       </pc:docMkLst>
       <pc:sldChg chg="addSp delSp modSp new mod">
-        <pc:chgData name="Diego Hernando Miranda Jimenez" userId="4eb28599-f441-4de0-a58d-80b2e80d624c" providerId="ADAL" clId="{4DB6BEFE-0A31-43AF-A2A0-D92ECB6A0142}" dt="2026-04-01T16:18:35.059" v="4" actId="1076"/>
+        <pc:chgData name="Diego Hernando Miranda Jimenez" userId="4eb28599-f441-4de0-a58d-80b2e80d624c" providerId="ADAL" clId="{4DB6BEFE-0A31-43AF-A2A0-D92ECB6A0142}" dt="2026-04-02T00:01:28.390" v="5" actId="1076"/>
         <pc:sldMkLst>
           <pc:docMk/>
           <pc:sldMk cId="2808884712" sldId="256"/>
@@ -139,7 +139,7 @@
           </ac:spMkLst>
         </pc:spChg>
         <pc:picChg chg="add mod">
-          <ac:chgData name="Diego Hernando Miranda Jimenez" userId="4eb28599-f441-4de0-a58d-80b2e80d624c" providerId="ADAL" clId="{4DB6BEFE-0A31-43AF-A2A0-D92ECB6A0142}" dt="2026-04-01T16:18:35.059" v="4" actId="1076"/>
+          <ac:chgData name="Diego Hernando Miranda Jimenez" userId="4eb28599-f441-4de0-a58d-80b2e80d624c" providerId="ADAL" clId="{4DB6BEFE-0A31-43AF-A2A0-D92ECB6A0142}" dt="2026-04-02T00:01:28.390" v="5" actId="1076"/>
           <ac:picMkLst>
             <pc:docMk/>
             <pc:sldMk cId="2808884712" sldId="256"/>
@@ -3409,7 +3409,7 @@
         </p:blipFill>
         <p:spPr>
           <a:xfrm>
-            <a:off x="2633179" y="886059"/>
+            <a:off x="2422867" y="822051"/>
             <a:ext cx="6925642" cy="4829849"/>
           </a:xfrm>
           <a:prstGeom prst="rect">

</xml_diff>